<commit_message>
Score on the arena mark scale (D1 25 / D2 35 / D3 40)
The tiers are not weighted equally, so the mean of levels was not the arena
mark. Projected 59.5/100 = 18.8 + 23.6 + 17.2. Adds the PDF deck for upload
and fixes the slide-1 title overlap.

Co-Authored-By: Claude Opus 5 <noreply@anthropic.com>
</commit_message>
<xml_diff>
--- a/AHC_2slide_submission.pptx
+++ b/AHC_2slide_submission.pptx
@@ -3185,8 +3185,8 @@
         </p:nvSpPr>
         <p:spPr>
           <a:xfrm>
-            <a:off x="502920" y="384048"/>
-            <a:ext cx="8686800" cy="457200"/>
+            <a:off x="502920" y="365760"/>
+            <a:ext cx="8595360" cy="502920"/>
           </a:xfrm>
           <a:prstGeom prst="rect">
             <a:avLst/>
@@ -3205,13 +3205,13 @@
               </a:lnSpc>
             </a:pPr>
             <a:r>
-              <a:rPr sz="2700" b="1">
+              <a:rPr sz="2600" b="1">
                 <a:solidFill>
                   <a:srgbClr val="E8ECF4"/>
                 </a:solidFill>
                 <a:latin typeface="Segoe UI"/>
               </a:rPr>
-              <a:t>Real-time video anomaly detection on a 4 GB laptop GPU</a:t>
+              <a:t>Video anomaly detection on a 4 GB laptop GPU</a:t>
             </a:r>
           </a:p>
         </p:txBody>
@@ -3224,8 +3224,8 @@
         </p:nvSpPr>
         <p:spPr>
           <a:xfrm>
-            <a:off x="502920" y="932688"/>
-            <a:ext cx="10515600" cy="310896"/>
+            <a:off x="502920" y="950976"/>
+            <a:ext cx="8595360" cy="310896"/>
           </a:xfrm>
           <a:prstGeom prst="rect">
             <a:avLst/>
@@ -3250,7 +3250,7 @@
                 </a:solidFill>
                 <a:latin typeface="Segoe UI"/>
               </a:rPr>
-              <a:t>Frozen vision-language encoder + two small trained heads  ·  11 anomaly classes  ·  RTX 3050 Laptop, 4 GB VRAM</a:t>
+              <a:t>Frozen vision-language encoder + two small trained heads  ·  11 classes  ·  20.3x real time on an RTX 3050 Laptop</a:t>
             </a:r>
           </a:p>
         </p:txBody>
@@ -3335,7 +3335,7 @@
                 </a:solidFill>
                 <a:latin typeface="Segoe UI"/>
               </a:rPr>
-              <a:t>0.618</a:t>
+              <a:t>59.5 / 100</a:t>
             </a:r>
           </a:p>
         </p:txBody>
@@ -3374,7 +3374,7 @@
                 </a:solidFill>
                 <a:latin typeface="Segoe UI"/>
               </a:rPr>
-              <a:t>OVERALL, PUBLIC TEST (34 VIDEOS)</a:t>
+              <a:t>PROJECTED MARKS · PUBLIC TEST</a:t>
             </a:r>
           </a:p>
         </p:txBody>
@@ -5040,7 +5040,7 @@
         </p:nvSpPr>
         <p:spPr>
           <a:xfrm>
-            <a:off x="502920" y="4343400"/>
+            <a:off x="502920" y="4224528"/>
             <a:ext cx="6766560" cy="274320"/>
           </a:xfrm>
           <a:prstGeom prst="rect">
@@ -5066,7 +5066,7 @@
                 </a:solidFill>
                 <a:latin typeface="Segoe UI"/>
               </a:rPr>
-              <a:t>FINAL, BY TASK TIER</a:t>
+              <a:t>FINAL, BY DIFFICULTY TIER</a:t>
             </a:r>
           </a:p>
         </p:txBody>
@@ -5079,12 +5079,12 @@
         </p:nvSpPr>
         <p:spPr>
           <a:xfrm>
-            <a:off x="502920" y="4672584"/>
-            <a:ext cx="2121408" cy="914400"/>
+            <a:off x="502920" y="4535424"/>
+            <a:ext cx="2121408" cy="1078992"/>
           </a:xfrm>
           <a:prstGeom prst="roundRect">
             <a:avLst>
-              <a:gd name="adj" fmla="val 12000"/>
+              <a:gd name="adj" fmla="val 10000"/>
             </a:avLst>
           </a:prstGeom>
           <a:solidFill>
@@ -5125,8 +5125,8 @@
         </p:nvSpPr>
         <p:spPr>
           <a:xfrm>
-            <a:off x="649224" y="4773168"/>
-            <a:ext cx="1828800" cy="237744"/>
+            <a:off x="649224" y="4636008"/>
+            <a:ext cx="1828800" cy="219456"/>
           </a:xfrm>
           <a:prstGeom prst="rect">
             <a:avLst/>
@@ -5151,7 +5151,7 @@
                 </a:solidFill>
                 <a:latin typeface="Segoe UI"/>
               </a:rPr>
-              <a:t>Level 1</a:t>
+              <a:t>Difficulty 1</a:t>
             </a:r>
           </a:p>
         </p:txBody>
@@ -5164,8 +5164,8 @@
         </p:nvSpPr>
         <p:spPr>
           <a:xfrm>
-            <a:off x="649224" y="5001768"/>
-            <a:ext cx="1828800" cy="365760"/>
+            <a:off x="649224" y="4846320"/>
+            <a:ext cx="1828800" cy="329184"/>
           </a:xfrm>
           <a:prstGeom prst="rect">
             <a:avLst/>
@@ -5184,7 +5184,7 @@
               </a:lnSpc>
             </a:pPr>
             <a:r>
-              <a:rPr sz="2000" b="1">
+              <a:rPr sz="1900" b="1">
                 <a:solidFill>
                   <a:srgbClr val="E8ECF4"/>
                 </a:solidFill>
@@ -5203,8 +5203,8 @@
         </p:nvSpPr>
         <p:spPr>
           <a:xfrm>
-            <a:off x="649224" y="5358384"/>
-            <a:ext cx="1874519" cy="219456"/>
+            <a:off x="649224" y="5193792"/>
+            <a:ext cx="1828800" cy="219456"/>
           </a:xfrm>
           <a:prstGeom prst="rect">
             <a:avLst/>
@@ -5223,31 +5223,70 @@
               </a:lnSpc>
             </a:pPr>
             <a:r>
-              <a:rPr sz="800" b="0">
-                <a:solidFill>
-                  <a:srgbClr val="8B93A7"/>
+              <a:rPr sz="1000" b="1">
+                <a:solidFill>
+                  <a:srgbClr val="F5A623"/>
                 </a:solidFill>
                 <a:latin typeface="Segoe UI"/>
               </a:rPr>
-              <a:t>clip label · anomaly acc 23/24</a:t>
-            </a:r>
-          </a:p>
-        </p:txBody>
-      </p:sp>
-      <p:sp>
-        <p:nvSpPr>
-          <p:cNvPr id="12" name="Rounded Rectangle 11"/>
+              <a:t>18.8 / 25 marks</a:t>
+            </a:r>
+          </a:p>
+        </p:txBody>
+      </p:sp>
+      <p:sp>
+        <p:nvSpPr>
+          <p:cNvPr id="12" name="TextBox 11"/>
+          <p:cNvSpPr txBox="1"/>
+          <p:nvPr/>
+        </p:nvSpPr>
+        <p:spPr>
+          <a:xfrm>
+            <a:off x="649224" y="5394960"/>
+            <a:ext cx="1874519" cy="201168"/>
+          </a:xfrm>
+          <a:prstGeom prst="rect">
+            <a:avLst/>
+          </a:prstGeom>
+          <a:noFill/>
+        </p:spPr>
+        <p:txBody>
+          <a:bodyPr wrap="square" anchor="t" lIns="0" rIns="0" tIns="0" bIns="0">
+            <a:spAutoFit/>
+          </a:bodyPr>
+          <a:lstStyle/>
+          <a:p>
+            <a:pPr algn="l">
+              <a:lnSpc>
+                <a:spcPct val="100000"/>
+              </a:lnSpc>
+            </a:pPr>
+            <a:r>
+              <a:rPr sz="800" b="0">
+                <a:solidFill>
+                  <a:srgbClr val="8B93A7"/>
+                </a:solidFill>
+                <a:latin typeface="Segoe UI"/>
+              </a:rPr>
+              <a:t>anomaly acc 23 of 24</a:t>
+            </a:r>
+          </a:p>
+        </p:txBody>
+      </p:sp>
+      <p:sp>
+        <p:nvSpPr>
+          <p:cNvPr id="13" name="Rounded Rectangle 12"/>
           <p:cNvSpPr/>
           <p:nvPr/>
         </p:nvSpPr>
         <p:spPr>
           <a:xfrm>
-            <a:off x="2807208" y="4672584"/>
-            <a:ext cx="2121408" cy="914400"/>
+            <a:off x="2807208" y="4535424"/>
+            <a:ext cx="2121408" cy="1078992"/>
           </a:xfrm>
           <a:prstGeom prst="roundRect">
             <a:avLst>
-              <a:gd name="adj" fmla="val 12000"/>
+              <a:gd name="adj" fmla="val 10000"/>
             </a:avLst>
           </a:prstGeom>
           <a:solidFill>
@@ -5282,14 +5321,14 @@
       </p:sp>
       <p:sp>
         <p:nvSpPr>
-          <p:cNvPr id="13" name="TextBox 12"/>
+          <p:cNvPr id="14" name="TextBox 13"/>
           <p:cNvSpPr txBox="1"/>
           <p:nvPr/>
         </p:nvSpPr>
         <p:spPr>
           <a:xfrm>
-            <a:off x="2953512" y="4773168"/>
-            <a:ext cx="1828800" cy="237744"/>
+            <a:off x="2953512" y="4636008"/>
+            <a:ext cx="1828800" cy="219456"/>
           </a:xfrm>
           <a:prstGeom prst="rect">
             <a:avLst/>
@@ -5314,21 +5353,21 @@
                 </a:solidFill>
                 <a:latin typeface="Segoe UI"/>
               </a:rPr>
-              <a:t>Level 2</a:t>
-            </a:r>
-          </a:p>
-        </p:txBody>
-      </p:sp>
-      <p:sp>
-        <p:nvSpPr>
-          <p:cNvPr id="14" name="TextBox 13"/>
+              <a:t>Difficulty 2</a:t>
+            </a:r>
+          </a:p>
+        </p:txBody>
+      </p:sp>
+      <p:sp>
+        <p:nvSpPr>
+          <p:cNvPr id="15" name="TextBox 14"/>
           <p:cNvSpPr txBox="1"/>
           <p:nvPr/>
         </p:nvSpPr>
         <p:spPr>
           <a:xfrm>
-            <a:off x="2953512" y="5001768"/>
-            <a:ext cx="1828800" cy="365760"/>
+            <a:off x="2953512" y="4846320"/>
+            <a:ext cx="1828800" cy="329184"/>
           </a:xfrm>
           <a:prstGeom prst="rect">
             <a:avLst/>
@@ -5347,7 +5386,7 @@
               </a:lnSpc>
             </a:pPr>
             <a:r>
-              <a:rPr sz="2000" b="1">
+              <a:rPr sz="1900" b="1">
                 <a:solidFill>
                   <a:srgbClr val="E8ECF4"/>
                 </a:solidFill>
@@ -5360,14 +5399,14 @@
       </p:sp>
       <p:sp>
         <p:nvSpPr>
-          <p:cNvPr id="15" name="TextBox 14"/>
+          <p:cNvPr id="16" name="TextBox 15"/>
           <p:cNvSpPr txBox="1"/>
           <p:nvPr/>
         </p:nvSpPr>
         <p:spPr>
           <a:xfrm>
-            <a:off x="2953512" y="5358384"/>
-            <a:ext cx="1874519" cy="219456"/>
+            <a:off x="2953512" y="5193792"/>
+            <a:ext cx="1828800" cy="219456"/>
           </a:xfrm>
           <a:prstGeom prst="rect">
             <a:avLst/>
@@ -5386,31 +5425,70 @@
               </a:lnSpc>
             </a:pPr>
             <a:r>
-              <a:rPr sz="800" b="0">
-                <a:solidFill>
-                  <a:srgbClr val="8B93A7"/>
+              <a:rPr sz="1000" b="1">
+                <a:solidFill>
+                  <a:srgbClr val="F5A623"/>
                 </a:solidFill>
                 <a:latin typeface="Segoe UI"/>
               </a:rPr>
-              <a:t>timed events · both normals silent</a:t>
-            </a:r>
-          </a:p>
-        </p:txBody>
-      </p:sp>
-      <p:sp>
-        <p:nvSpPr>
-          <p:cNvPr id="16" name="Rounded Rectangle 15"/>
+              <a:t>23.6 / 35 marks</a:t>
+            </a:r>
+          </a:p>
+        </p:txBody>
+      </p:sp>
+      <p:sp>
+        <p:nvSpPr>
+          <p:cNvPr id="17" name="TextBox 16"/>
+          <p:cNvSpPr txBox="1"/>
+          <p:nvPr/>
+        </p:nvSpPr>
+        <p:spPr>
+          <a:xfrm>
+            <a:off x="2953512" y="5394960"/>
+            <a:ext cx="1874519" cy="201168"/>
+          </a:xfrm>
+          <a:prstGeom prst="rect">
+            <a:avLst/>
+          </a:prstGeom>
+          <a:noFill/>
+        </p:spPr>
+        <p:txBody>
+          <a:bodyPr wrap="square" anchor="t" lIns="0" rIns="0" tIns="0" bIns="0">
+            <a:spAutoFit/>
+          </a:bodyPr>
+          <a:lstStyle/>
+          <a:p>
+            <a:pPr algn="l">
+              <a:lnSpc>
+                <a:spcPct val="100000"/>
+              </a:lnSpc>
+            </a:pPr>
+            <a:r>
+              <a:rPr sz="800" b="0">
+                <a:solidFill>
+                  <a:srgbClr val="8B93A7"/>
+                </a:solidFill>
+                <a:latin typeface="Segoe UI"/>
+              </a:rPr>
+              <a:t>both normals silent</a:t>
+            </a:r>
+          </a:p>
+        </p:txBody>
+      </p:sp>
+      <p:sp>
+        <p:nvSpPr>
+          <p:cNvPr id="18" name="Rounded Rectangle 17"/>
           <p:cNvSpPr/>
           <p:nvPr/>
         </p:nvSpPr>
         <p:spPr>
           <a:xfrm>
-            <a:off x="5111496" y="4672584"/>
-            <a:ext cx="2121408" cy="914400"/>
+            <a:off x="5111496" y="4535424"/>
+            <a:ext cx="2121408" cy="1078992"/>
           </a:xfrm>
           <a:prstGeom prst="roundRect">
             <a:avLst>
-              <a:gd name="adj" fmla="val 12000"/>
+              <a:gd name="adj" fmla="val 10000"/>
             </a:avLst>
           </a:prstGeom>
           <a:solidFill>
@@ -5445,14 +5523,14 @@
       </p:sp>
       <p:sp>
         <p:nvSpPr>
-          <p:cNvPr id="17" name="TextBox 16"/>
+          <p:cNvPr id="19" name="TextBox 18"/>
           <p:cNvSpPr txBox="1"/>
           <p:nvPr/>
         </p:nvSpPr>
         <p:spPr>
           <a:xfrm>
-            <a:off x="5257800" y="4773168"/>
-            <a:ext cx="1828800" cy="237744"/>
+            <a:off x="5257800" y="4636008"/>
+            <a:ext cx="1828800" cy="219456"/>
           </a:xfrm>
           <a:prstGeom prst="rect">
             <a:avLst/>
@@ -5477,21 +5555,21 @@
                 </a:solidFill>
                 <a:latin typeface="Segoe UI"/>
               </a:rPr>
-              <a:t>Level 3</a:t>
-            </a:r>
-          </a:p>
-        </p:txBody>
-      </p:sp>
-      <p:sp>
-        <p:nvSpPr>
-          <p:cNvPr id="18" name="TextBox 17"/>
+              <a:t>Difficulty 3</a:t>
+            </a:r>
+          </a:p>
+        </p:txBody>
+      </p:sp>
+      <p:sp>
+        <p:nvSpPr>
+          <p:cNvPr id="20" name="TextBox 19"/>
           <p:cNvSpPr txBox="1"/>
           <p:nvPr/>
         </p:nvSpPr>
         <p:spPr>
           <a:xfrm>
-            <a:off x="5257800" y="5001768"/>
-            <a:ext cx="1828800" cy="365760"/>
+            <a:off x="5257800" y="4846320"/>
+            <a:ext cx="1828800" cy="329184"/>
           </a:xfrm>
           <a:prstGeom prst="rect">
             <a:avLst/>
@@ -5510,7 +5588,7 @@
               </a:lnSpc>
             </a:pPr>
             <a:r>
-              <a:rPr sz="2000" b="1">
+              <a:rPr sz="1900" b="1">
                 <a:solidFill>
                   <a:srgbClr val="E8ECF4"/>
                 </a:solidFill>
@@ -5523,14 +5601,14 @@
       </p:sp>
       <p:sp>
         <p:nvSpPr>
-          <p:cNvPr id="19" name="TextBox 18"/>
+          <p:cNvPr id="21" name="TextBox 20"/>
           <p:cNvSpPr txBox="1"/>
           <p:nvPr/>
         </p:nvSpPr>
         <p:spPr>
           <a:xfrm>
-            <a:off x="5257800" y="5358384"/>
-            <a:ext cx="1874519" cy="219456"/>
+            <a:off x="5257800" y="5193792"/>
+            <a:ext cx="1828800" cy="219456"/>
           </a:xfrm>
           <a:prstGeom prst="rect">
             <a:avLst/>
@@ -5549,20 +5627,59 @@
               </a:lnSpc>
             </a:pPr>
             <a:r>
-              <a:rPr sz="800" b="0">
-                <a:solidFill>
-                  <a:srgbClr val="8B93A7"/>
+              <a:rPr sz="1000" b="1">
+                <a:solidFill>
+                  <a:srgbClr val="F5A623"/>
                 </a:solidFill>
                 <a:latin typeface="Segoe UI"/>
               </a:rPr>
-              <a:t>long footage · timing weighted</a:t>
-            </a:r>
-          </a:p>
-        </p:txBody>
-      </p:sp>
-      <p:sp>
-        <p:nvSpPr>
-          <p:cNvPr id="20" name="TextBox 19"/>
+              <a:t>17.2 / 40 marks</a:t>
+            </a:r>
+          </a:p>
+        </p:txBody>
+      </p:sp>
+      <p:sp>
+        <p:nvSpPr>
+          <p:cNvPr id="22" name="TextBox 21"/>
+          <p:cNvSpPr txBox="1"/>
+          <p:nvPr/>
+        </p:nvSpPr>
+        <p:spPr>
+          <a:xfrm>
+            <a:off x="5257800" y="5394960"/>
+            <a:ext cx="1874519" cy="201168"/>
+          </a:xfrm>
+          <a:prstGeom prst="rect">
+            <a:avLst/>
+          </a:prstGeom>
+          <a:noFill/>
+        </p:spPr>
+        <p:txBody>
+          <a:bodyPr wrap="square" anchor="t" lIns="0" rIns="0" tIns="0" bIns="0">
+            <a:spAutoFit/>
+          </a:bodyPr>
+          <a:lstStyle/>
+          <a:p>
+            <a:pPr algn="l">
+              <a:lnSpc>
+                <a:spcPct val="100000"/>
+              </a:lnSpc>
+            </a:pPr>
+            <a:r>
+              <a:rPr sz="800" b="0">
+                <a:solidFill>
+                  <a:srgbClr val="8B93A7"/>
+                </a:solidFill>
+                <a:latin typeface="Segoe UI"/>
+              </a:rPr>
+              <a:t>weakest, and worth most</a:t>
+            </a:r>
+          </a:p>
+        </p:txBody>
+      </p:sp>
+      <p:sp>
+        <p:nvSpPr>
+          <p:cNvPr id="23" name="TextBox 22"/>
           <p:cNvSpPr txBox="1"/>
           <p:nvPr/>
         </p:nvSpPr>
@@ -5610,14 +5727,14 @@
                 </a:solidFill>
                 <a:latin typeface="Segoe UI"/>
               </a:rPr>
-              <a:t>The decoder is tuned on 6 Level-2 and 4 Level-3 videos, so those thresholds are the least trustworthy part of the system. Ties break toward the least aggressive setting. Our scorer matches the published structure of the metric, but the arena's exact Level-2/3 weighting isn't published — it ranks configurations, it doesn't predict the leaderboard.</a:t>
-            </a:r>
-          </a:p>
-        </p:txBody>
-      </p:sp>
-      <p:sp>
-        <p:nvSpPr>
-          <p:cNvPr id="21" name="TextBox 20"/>
+              <a:t>The decoder is tuned on 6 Difficulty-2 and 4 Difficulty-3 videos, so those thresholds are the least trustworthy part of the system, and ties break toward the least aggressive setting. Our scorer matches the published structure of the metric; the exact within-tier weighting isn't published, so it ranks configurations rather than predicting the leaderboard.</a:t>
+            </a:r>
+          </a:p>
+        </p:txBody>
+      </p:sp>
+      <p:sp>
+        <p:nvSpPr>
+          <p:cNvPr id="24" name="TextBox 23"/>
           <p:cNvSpPr txBox="1"/>
           <p:nvPr/>
         </p:nvSpPr>
@@ -5656,7 +5773,7 @@
       </p:sp>
       <p:sp>
         <p:nvSpPr>
-          <p:cNvPr id="22" name="Rounded Rectangle 21"/>
+          <p:cNvPr id="25" name="Rounded Rectangle 24"/>
           <p:cNvSpPr/>
           <p:nvPr/>
         </p:nvSpPr>
@@ -5702,7 +5819,7 @@
       </p:sp>
       <p:sp>
         <p:nvSpPr>
-          <p:cNvPr id="23" name="TextBox 22"/>
+          <p:cNvPr id="26" name="TextBox 25"/>
           <p:cNvSpPr txBox="1"/>
           <p:nvPr/>
         </p:nvSpPr>
@@ -5741,7 +5858,7 @@
       </p:sp>
       <p:sp>
         <p:nvSpPr>
-          <p:cNvPr id="24" name="TextBox 23"/>
+          <p:cNvPr id="27" name="TextBox 26"/>
           <p:cNvSpPr txBox="1"/>
           <p:nvPr/>
         </p:nvSpPr>
@@ -5780,7 +5897,7 @@
       </p:sp>
       <p:sp>
         <p:nvSpPr>
-          <p:cNvPr id="25" name="TextBox 24"/>
+          <p:cNvPr id="28" name="TextBox 27"/>
           <p:cNvSpPr txBox="1"/>
           <p:nvPr/>
         </p:nvSpPr>
@@ -5819,7 +5936,7 @@
       </p:sp>
       <p:sp>
         <p:nvSpPr>
-          <p:cNvPr id="26" name="Rounded Rectangle 25"/>
+          <p:cNvPr id="29" name="Rounded Rectangle 28"/>
           <p:cNvSpPr/>
           <p:nvPr/>
         </p:nvSpPr>
@@ -5865,7 +5982,7 @@
       </p:sp>
       <p:sp>
         <p:nvSpPr>
-          <p:cNvPr id="27" name="TextBox 26"/>
+          <p:cNvPr id="30" name="TextBox 29"/>
           <p:cNvSpPr txBox="1"/>
           <p:nvPr/>
         </p:nvSpPr>
@@ -5904,7 +6021,7 @@
       </p:sp>
       <p:sp>
         <p:nvSpPr>
-          <p:cNvPr id="28" name="TextBox 27"/>
+          <p:cNvPr id="31" name="TextBox 30"/>
           <p:cNvSpPr txBox="1"/>
           <p:nvPr/>
         </p:nvSpPr>
@@ -5943,7 +6060,7 @@
       </p:sp>
       <p:sp>
         <p:nvSpPr>
-          <p:cNvPr id="29" name="TextBox 28"/>
+          <p:cNvPr id="32" name="TextBox 31"/>
           <p:cNvSpPr txBox="1"/>
           <p:nvPr/>
         </p:nvSpPr>
@@ -5982,7 +6099,7 @@
       </p:sp>
       <p:sp>
         <p:nvSpPr>
-          <p:cNvPr id="30" name="Rounded Rectangle 29"/>
+          <p:cNvPr id="33" name="Rounded Rectangle 32"/>
           <p:cNvSpPr/>
           <p:nvPr/>
         </p:nvSpPr>
@@ -6028,7 +6145,7 @@
       </p:sp>
       <p:sp>
         <p:nvSpPr>
-          <p:cNvPr id="31" name="TextBox 30"/>
+          <p:cNvPr id="34" name="TextBox 33"/>
           <p:cNvSpPr txBox="1"/>
           <p:nvPr/>
         </p:nvSpPr>
@@ -6067,7 +6184,7 @@
       </p:sp>
       <p:sp>
         <p:nvSpPr>
-          <p:cNvPr id="32" name="TextBox 31"/>
+          <p:cNvPr id="35" name="TextBox 34"/>
           <p:cNvSpPr txBox="1"/>
           <p:nvPr/>
         </p:nvSpPr>
@@ -6106,7 +6223,7 @@
       </p:sp>
       <p:sp>
         <p:nvSpPr>
-          <p:cNvPr id="33" name="TextBox 32"/>
+          <p:cNvPr id="36" name="TextBox 35"/>
           <p:cNvSpPr txBox="1"/>
           <p:nvPr/>
         </p:nvSpPr>
@@ -6145,18 +6262,18 @@
       </p:sp>
       <p:sp>
         <p:nvSpPr>
-          <p:cNvPr id="34" name="Rounded Rectangle 33"/>
+          <p:cNvPr id="37" name="Rounded Rectangle 36"/>
           <p:cNvSpPr/>
           <p:nvPr/>
         </p:nvSpPr>
         <p:spPr>
           <a:xfrm>
             <a:off x="7543800" y="5961888"/>
-            <a:ext cx="4160520" cy="621792"/>
+            <a:ext cx="4160520" cy="749808"/>
           </a:xfrm>
           <a:prstGeom prst="roundRect">
             <a:avLst>
-              <a:gd name="adj" fmla="val 15000"/>
+              <a:gd name="adj" fmla="val 12000"/>
             </a:avLst>
           </a:prstGeom>
           <a:solidFill>
@@ -6191,14 +6308,14 @@
       </p:sp>
       <p:sp>
         <p:nvSpPr>
-          <p:cNvPr id="35" name="TextBox 34"/>
+          <p:cNvPr id="38" name="TextBox 37"/>
           <p:cNvSpPr txBox="1"/>
           <p:nvPr/>
         </p:nvSpPr>
         <p:spPr>
           <a:xfrm>
-            <a:off x="7726679" y="6053328"/>
-            <a:ext cx="3794760" cy="219456"/>
+            <a:off x="7726679" y="6062472"/>
+            <a:ext cx="3794760" cy="201168"/>
           </a:xfrm>
           <a:prstGeom prst="rect">
             <a:avLst/>
@@ -6230,14 +6347,14 @@
       </p:sp>
       <p:sp>
         <p:nvSpPr>
-          <p:cNvPr id="36" name="TextBox 35"/>
+          <p:cNvPr id="39" name="TextBox 38"/>
           <p:cNvSpPr txBox="1"/>
           <p:nvPr/>
         </p:nvSpPr>
         <p:spPr>
           <a:xfrm>
-            <a:off x="7726679" y="6272784"/>
-            <a:ext cx="3840480" cy="237744"/>
+            <a:off x="7726679" y="6281928"/>
+            <a:ext cx="3822191" cy="365760"/>
           </a:xfrm>
           <a:prstGeom prst="rect">
             <a:avLst/>
@@ -6252,7 +6369,7 @@
           <a:p>
             <a:pPr algn="l">
               <a:lnSpc>
-                <a:spcPct val="100000"/>
+                <a:spcPct val="105000"/>
               </a:lnSpc>
             </a:pPr>
             <a:r>

</xml_diff>

<commit_message>
Record real arena results and the measured decoder ceiling
60.7/100 (D1 15.9, D2 24.6, D3 20.2). Oracle search over ~15k decoder configs
scoring each video at its own best setting tops out near 61, and two D3 videos
sit exactly at their ceiling - no threshold ranks their events. Deck and
write-up now carry arena marks rather than local estimates.

Co-Authored-By: Claude Opus 5 <noreply@anthropic.com>
</commit_message>
<xml_diff>
--- a/AHC_2slide_submission.pptx
+++ b/AHC_2slide_submission.pptx
@@ -3335,7 +3335,7 @@
                 </a:solidFill>
                 <a:latin typeface="Segoe UI"/>
               </a:rPr>
-              <a:t>59.5 / 100</a:t>
+              <a:t>60.7 / 100</a:t>
             </a:r>
           </a:p>
         </p:txBody>
@@ -3374,7 +3374,7 @@
                 </a:solidFill>
                 <a:latin typeface="Segoe UI"/>
               </a:rPr>
-              <a:t>PROJECTED MARKS · PUBLIC TEST</a:t>
+              <a:t>ARENA SCORE · PUBLIC TEST</a:t>
             </a:r>
           </a:p>
         </p:txBody>
@@ -5003,7 +5003,7 @@
                 </a:solidFill>
                 <a:latin typeface="Segoe UI"/>
               </a:rPr>
-              <a:t>Every number below is the same 34-video public test set, scored locally against a re-implementation of the arena metric</a:t>
+              <a:t>Real arena marks across 15 scored runs. D1 is worth 25, D2 35, D3 40.</a:t>
             </a:r>
           </a:p>
         </p:txBody>
@@ -5190,7 +5190,7 @@
                 </a:solidFill>
                 <a:latin typeface="Segoe UI"/>
               </a:rPr>
-              <a:t>0.750</a:t>
+              <a:t>63.7%</a:t>
             </a:r>
           </a:p>
         </p:txBody>
@@ -5229,7 +5229,7 @@
                 </a:solidFill>
                 <a:latin typeface="Segoe UI"/>
               </a:rPr>
-              <a:t>18.8 / 25 marks</a:t>
+              <a:t>15.9 / 25 marks</a:t>
             </a:r>
           </a:p>
         </p:txBody>
@@ -5268,7 +5268,7 @@
                 </a:solidFill>
                 <a:latin typeface="Segoe UI"/>
               </a:rPr>
-              <a:t>anomaly acc 23 of 24</a:t>
+              <a:t>class confusion is the wall</a:t>
             </a:r>
           </a:p>
         </p:txBody>
@@ -5392,7 +5392,7 @@
                 </a:solidFill>
                 <a:latin typeface="Segoe UI"/>
               </a:rPr>
-              <a:t>0.674</a:t>
+              <a:t>70.3%</a:t>
             </a:r>
           </a:p>
         </p:txBody>
@@ -5431,7 +5431,7 @@
                 </a:solidFill>
                 <a:latin typeface="Segoe UI"/>
               </a:rPr>
-              <a:t>23.6 / 35 marks</a:t>
+              <a:t>24.6 / 35 marks</a:t>
             </a:r>
           </a:p>
         </p:txBody>
@@ -5470,7 +5470,7 @@
                 </a:solidFill>
                 <a:latin typeface="Segoe UI"/>
               </a:rPr>
-              <a:t>both normals silent</a:t>
+              <a:t>oracle ceiling 24.8</a:t>
             </a:r>
           </a:p>
         </p:txBody>
@@ -5594,7 +5594,7 @@
                 </a:solidFill>
                 <a:latin typeface="Segoe UI"/>
               </a:rPr>
-              <a:t>0.430</a:t>
+              <a:t>50.4%</a:t>
             </a:r>
           </a:p>
         </p:txBody>
@@ -5633,7 +5633,7 @@
                 </a:solidFill>
                 <a:latin typeface="Segoe UI"/>
               </a:rPr>
-              <a:t>17.2 / 40 marks</a:t>
+              <a:t>20.2 / 40 marks</a:t>
             </a:r>
           </a:p>
         </p:txBody>
@@ -5672,7 +5672,7 @@
                 </a:solidFill>
                 <a:latin typeface="Segoe UI"/>
               </a:rPr>
-              <a:t>weakest, and worth most</a:t>
+              <a:t>oracle ceiling 19.8</a:t>
             </a:r>
           </a:p>
         </p:txBody>
@@ -6177,7 +6177,7 @@
                 </a:solidFill>
                 <a:latin typeface="Segoe UI"/>
               </a:rPr>
-              <a:t>Merge gaps sized to real events</a:t>
+              <a:t>We proved when to stop tuning</a:t>
             </a:r>
           </a:p>
         </p:txBody>
@@ -6216,7 +6216,7 @@
                 </a:solidFill>
                 <a:latin typeface="Segoe UI"/>
               </a:rPr>
-              <a:t>Level-3 events run 45-125 s. A 5 s merge ceiling shattered one event into 13 fragments — and only the best-overlapping fragment can ever match.</a:t>
+              <a:t>Oracle search over ~15,000 decoder configs, scoring each video at its own best setting, tops out near 61 marks — we are at 60.7. Two D3 videos sit exactly at their ceiling: no threshold can rank their events.</a:t>
             </a:r>
           </a:p>
         </p:txBody>
@@ -6251,11 +6251,11 @@
             <a:r>
               <a:rPr sz="900" b="1">
                 <a:solidFill>
-                  <a:srgbClr val="4ADE80"/>
+                  <a:srgbClr val="F87171"/>
                 </a:solidFill>
                 <a:latin typeface="Segoe UI"/>
               </a:rPr>
-              <a:t>T031 0.200 → 0.848</a:t>
+              <a:t>Decoder is finished; encoder is the wall</a:t>
             </a:r>
           </a:p>
         </p:txBody>
@@ -6379,7 +6379,7 @@
                 </a:solidFill>
                 <a:latin typeface="Segoe UI"/>
               </a:rPr>
-              <a:t>Larger SigLIP (segfaults at 4 GB) · zero-shot prompt fusion (0.29 alone, no lift) · one shared threshold for all tiers</a:t>
+              <a:t>Contrast-to-baseline features: +0.8% held-out, but test AUC collapsed 0.86→0.53 · logit adjustment for rare classes: zero lift · TTA: zero lift</a:t>
             </a:r>
           </a:p>
         </p:txBody>

</xml_diff>

<commit_message>
Deck now reports the private evaluation set
Progression chart rebuilt from the four scored eval runs (39.9 -> 54.8), tier
cards show eval marks, and the third finding is the annotation-granularity
lesson that actually moved D3.

Co-Authored-By: Claude Opus 5 <noreply@anthropic.com>
</commit_message>
<xml_diff>
--- a/AHC_2slide_submission.pptx
+++ b/AHC_2slide_submission.pptx
@@ -3335,7 +3335,7 @@
                 </a:solidFill>
                 <a:latin typeface="Segoe UI"/>
               </a:rPr>
-              <a:t>60.7 / 100</a:t>
+              <a:t>54.8 / 100</a:t>
             </a:r>
           </a:p>
         </p:txBody>
@@ -3374,7 +3374,7 @@
                 </a:solidFill>
                 <a:latin typeface="Segoe UI"/>
               </a:rPr>
-              <a:t>ARENA SCORE · PUBLIC TEST</a:t>
+              <a:t>PRIVATE EVALUATION SET</a:t>
             </a:r>
           </a:p>
         </p:txBody>
@@ -5003,7 +5003,7 @@
                 </a:solidFill>
                 <a:latin typeface="Segoe UI"/>
               </a:rPr>
-              <a:t>Real arena marks across 15 scored runs. D1 is worth 25, D2 35, D3 40.</a:t>
+              <a:t>Private evaluation set, 28 videos. D1 is worth 25, D2 35, D3 40.</a:t>
             </a:r>
           </a:p>
         </p:txBody>
@@ -5190,7 +5190,7 @@
                 </a:solidFill>
                 <a:latin typeface="Segoe UI"/>
               </a:rPr>
-              <a:t>63.7%</a:t>
+              <a:t>56.2%</a:t>
             </a:r>
           </a:p>
         </p:txBody>
@@ -5229,7 +5229,7 @@
                 </a:solidFill>
                 <a:latin typeface="Segoe UI"/>
               </a:rPr>
-              <a:t>15.9 / 25 marks</a:t>
+              <a:t>14.1 / 25 marks</a:t>
             </a:r>
           </a:p>
         </p:txBody>
@@ -5392,7 +5392,7 @@
                 </a:solidFill>
                 <a:latin typeface="Segoe UI"/>
               </a:rPr>
-              <a:t>70.3%</a:t>
+              <a:t>51.0%</a:t>
             </a:r>
           </a:p>
         </p:txBody>
@@ -5431,7 +5431,7 @@
                 </a:solidFill>
                 <a:latin typeface="Segoe UI"/>
               </a:rPr>
-              <a:t>24.6 / 35 marks</a:t>
+              <a:t>17.9 / 35 marks</a:t>
             </a:r>
           </a:p>
         </p:txBody>
@@ -5470,7 +5470,7 @@
                 </a:solidFill>
                 <a:latin typeface="Segoe UI"/>
               </a:rPr>
-              <a:t>oracle ceiling 24.8</a:t>
+              <a:t>event is part of the clip</a:t>
             </a:r>
           </a:p>
         </p:txBody>
@@ -5594,7 +5594,7 @@
                 </a:solidFill>
                 <a:latin typeface="Segoe UI"/>
               </a:rPr>
-              <a:t>50.4%</a:t>
+              <a:t>57.0%</a:t>
             </a:r>
           </a:p>
         </p:txBody>
@@ -5633,7 +5633,7 @@
                 </a:solidFill>
                 <a:latin typeface="Segoe UI"/>
               </a:rPr>
-              <a:t>20.2 / 40 marks</a:t>
+              <a:t>22.8 / 40 marks</a:t>
             </a:r>
           </a:p>
         </p:txBody>
@@ -5672,7 +5672,7 @@
                 </a:solidFill>
                 <a:latin typeface="Segoe UI"/>
               </a:rPr>
-              <a:t>oracle ceiling 19.8</a:t>
+              <a:t>one span beat 4 windows</a:t>
             </a:r>
           </a:p>
         </p:txBody>
@@ -5727,7 +5727,7 @@
                 </a:solidFill>
                 <a:latin typeface="Segoe UI"/>
               </a:rPr>
-              <a:t>The decoder is tuned on 6 Difficulty-2 and 4 Difficulty-3 videos, so those thresholds are the least trustworthy part of the system, and ties break toward the least aggressive setting. Our scorer matches the published structure of the metric; the exact within-tier weighting isn't published, so it ranks configurations rather than predicting the leaderboard.</a:t>
+              <a:t>A decoder tuned to 60.7 on the practice pack scored 39.9 on the private set — thresholds fitted to 10 videos did not transfer, and the gain that mattered came from reading the scoring rule rather than from search. Class accuracy is now the binding constraint: stalled, road_spill, blocking and wrong_way are all 0% found, and no timing change fixes a wrong label.</a:t>
             </a:r>
           </a:p>
         </p:txBody>
@@ -6177,7 +6177,7 @@
                 </a:solidFill>
                 <a:latin typeface="Segoe UI"/>
               </a:rPr>
-              <a:t>We proved when to stop tuning</a:t>
+              <a:t>Annotation granularity beat every tuned threshold</a:t>
             </a:r>
           </a:p>
         </p:txBody>
@@ -6216,7 +6216,7 @@
                 </a:solidFill>
                 <a:latin typeface="Segoe UI"/>
               </a:rPr>
-              <a:t>Oracle search over ~15,000 decoder configs, scoring each video at its own best setting, tops out near 61 marks — we are at 60.7. Two D3 videos sit exactly at their ceiling: no threshold can rank their events.</a:t>
+              <a:t>Overlap is scored against the WHOLE ground-truth span, so our short windows each fell under the 0.5 gate and scored nothing. One span per video lifted D3 from 8.0 to 22.8 marks - after ~15,000 tuned configs had barely moved it.</a:t>
             </a:r>
           </a:p>
         </p:txBody>
@@ -6251,11 +6251,11 @@
             <a:r>
               <a:rPr sz="900" b="1">
                 <a:solidFill>
-                  <a:srgbClr val="F87171"/>
+                  <a:srgbClr val="4ADE80"/>
                 </a:solidFill>
                 <a:latin typeface="Segoe UI"/>
               </a:rPr>
-              <a:t>Decoder is finished; encoder is the wall</a:t>
+              <a:t>D3 20% -&gt; 57%; total 39.9 -&gt; 54.8</a:t>
             </a:r>
           </a:p>
         </p:txBody>

</xml_diff>